<commit_message>
Tinjau nama lintas tingkat tanpa ID kandidat dan terjemahkan hasil ke Bahasa Indonesia
</commit_message>
<xml_diff>
--- a/cleansing/management_summary/Salesforce_cleansing_management_summary.pptx
+++ b/cleansing/management_summary/Salesforce_cleansing_management_summary.pptx
@@ -503,7 +503,7 @@
           <a:lstStyle/>
           <a:p>
             <a:r>
-              <a:t>Snapshot: 29 October 2026. Source: Salesforce exports and Service Territory MASTER FIX workbook, draft PR #1. This deck presents proposed mappings; no Salesforce changes applied. Counts: 91,306 assessed; 52,419 keep; 8,595 update proposals; 3,105 duplicate mappings; 27,187 review. Slides are rendered charts.</a:t>
+              <a:t>Snapshot 29 Oktober 2026; terjemahan 30 Oktober 2026. Sumber: ekspor Salesforce dan workbook master, PR #1. Grafik merupakan gambar. Pemetaan belum disetujui; belum ada perubahan Salesforce. Jumlah record: 91.306 diperiksa; 52.419 dipertahankan; 8.595 usulan update; 3.105 pemetaan duplikat; 27.187 perlu ditinjau.</a:t>
             </a:r>
           </a:p>
         </p:txBody>
@@ -573,7 +573,7 @@
           <a:lstStyle/>
           <a:p>
             <a:r>
-              <a:t>Snapshot: 29 October 2026. Source: Salesforce exports and Service Territory MASTER FIX workbook, draft PR #1. This deck presents proposed mappings; no Salesforce changes applied. Counts: 91,306 assessed; 52,419 keep; 8,595 update proposals; 3,105 duplicate mappings; 27,187 review. Slides are rendered charts.</a:t>
+              <a:t>Snapshot 29 Oktober 2026; terjemahan 30 Oktober 2026. Sumber: ekspor Salesforce dan workbook master, PR #1. Grafik merupakan gambar. Pemetaan belum disetujui; belum ada perubahan Salesforce. Jumlah record: 91.306 diperiksa; 52.419 dipertahankan; 8.595 usulan update; 3.105 pemetaan duplikat; 27.187 perlu ditinjau.</a:t>
             </a:r>
           </a:p>
         </p:txBody>

</xml_diff>